<commit_message>
Updated presentation and link in corresponding README.MD
</commit_message>
<xml_diff>
--- a/4_Presentation/Hybrid-MLWP Enhancing Numerical Weather Prediction (NWP).pptx
+++ b/4_Presentation/Hybrid-MLWP Enhancing Numerical Weather Prediction (NWP).pptx
@@ -1061,6 +1061,38 @@
     </pc:docChg>
   </pc:docChgLst>
   <pc:docChgLst>
+    <pc:chgData name="Carl Schmidt" userId="2c689071ac8148fa" providerId="LiveId" clId="{1B9C89D6-6BDB-4AB2-BDA1-B1C42CB26CF4}"/>
+    <pc:docChg chg="undo custSel modSld">
+      <pc:chgData name="Carl Schmidt" userId="2c689071ac8148fa" providerId="LiveId" clId="{1B9C89D6-6BDB-4AB2-BDA1-B1C42CB26CF4}" dt="2026-03-01T17:30:29.697" v="40" actId="1038"/>
+      <pc:docMkLst>
+        <pc:docMk/>
+      </pc:docMkLst>
+      <pc:sldChg chg="modSp mod">
+        <pc:chgData name="Carl Schmidt" userId="2c689071ac8148fa" providerId="LiveId" clId="{1B9C89D6-6BDB-4AB2-BDA1-B1C42CB26CF4}" dt="2026-03-01T17:30:29.697" v="40" actId="1038"/>
+        <pc:sldMkLst>
+          <pc:docMk/>
+          <pc:sldMk cId="399998571" sldId="256"/>
+        </pc:sldMkLst>
+        <pc:spChg chg="mod">
+          <ac:chgData name="Carl Schmidt" userId="2c689071ac8148fa" providerId="LiveId" clId="{1B9C89D6-6BDB-4AB2-BDA1-B1C42CB26CF4}" dt="2026-03-01T17:30:29.697" v="40" actId="1038"/>
+          <ac:spMkLst>
+            <pc:docMk/>
+            <pc:sldMk cId="399998571" sldId="256"/>
+            <ac:spMk id="4" creationId="{AD4A5BAA-BEB4-C360-DED9-CAE9CEEDA75E}"/>
+          </ac:spMkLst>
+        </pc:spChg>
+        <pc:spChg chg="mod">
+          <ac:chgData name="Carl Schmidt" userId="2c689071ac8148fa" providerId="LiveId" clId="{1B9C89D6-6BDB-4AB2-BDA1-B1C42CB26CF4}" dt="2026-03-01T17:30:29.697" v="40" actId="1038"/>
+          <ac:spMkLst>
+            <pc:docMk/>
+            <pc:sldMk cId="399998571" sldId="256"/>
+            <ac:spMk id="6" creationId="{746D641E-1733-0D04-0F89-8588BC0E1983}"/>
+          </ac:spMkLst>
+        </pc:spChg>
+      </pc:sldChg>
+    </pc:docChg>
+  </pc:docChgLst>
+  <pc:docChgLst>
     <pc:chgData name="Carl Schmidt" userId="2c689071ac8148fa" providerId="LiveId" clId="{5B5AD961-57A7-4438-9B04-799F0CAA8BF2}"/>
     <pc:docChg chg="addSld delSld modSld">
       <pc:chgData name="Carl Schmidt" userId="2c689071ac8148fa" providerId="LiveId" clId="{5B5AD961-57A7-4438-9B04-799F0CAA8BF2}" dt="2026-03-01T17:26:44.077" v="4" actId="47"/>
@@ -4434,8 +4466,8 @@
         </p:nvSpPr>
         <p:spPr>
           <a:xfrm>
-            <a:off x="4743450" y="1225411"/>
-            <a:ext cx="7686675" cy="1077218"/>
+            <a:off x="4502821" y="1225411"/>
+            <a:ext cx="7686675" cy="461665"/>
           </a:xfrm>
           <a:prstGeom prst="rect">
             <a:avLst/>
@@ -4456,50 +4488,7 @@
                 </a:solidFill>
                 <a:latin typeface="Bahnschrift SemiBold SemiConden" panose="020B0502040204020203" pitchFamily="34" charset="0"/>
               </a:rPr>
-              <a:t>Improving traditional weather prediction (NWP)</a:t>
-            </a:r>
-            <a:br>
-              <a:rPr lang="en-US" sz="2400" b="1" dirty="0">
-                <a:solidFill>
-                  <a:srgbClr val="E9EAED"/>
-                </a:solidFill>
-                <a:latin typeface="Bahnschrift SemiBold SemiConden" panose="020B0502040204020203" pitchFamily="34" charset="0"/>
-              </a:rPr>
-            </a:br>
-            <a:r>
-              <a:rPr lang="en-US" sz="1600" b="1" dirty="0">
-                <a:solidFill>
-                  <a:srgbClr val="E9EAED"/>
-                </a:solidFill>
-                <a:latin typeface="Bahnschrift SemiBold SemiConden" panose="020B0502040204020203" pitchFamily="34" charset="0"/>
-              </a:rPr>
-              <a:t>using</a:t>
-            </a:r>
-            <a:br>
-              <a:rPr lang="en-US" sz="2400" b="1" dirty="0">
-                <a:solidFill>
-                  <a:srgbClr val="E9EAED"/>
-                </a:solidFill>
-                <a:latin typeface="Bahnschrift SemiBold SemiConden" panose="020B0502040204020203" pitchFamily="34" charset="0"/>
-              </a:rPr>
-            </a:br>
-            <a:r>
-              <a:rPr lang="en-US" sz="2400" b="1" dirty="0">
-                <a:solidFill>
-                  <a:srgbClr val="E9EAED"/>
-                </a:solidFill>
-                <a:latin typeface="Bahnschrift SemiBold SemiConden" panose="020B0502040204020203" pitchFamily="34" charset="0"/>
-              </a:rPr>
-              <a:t>machine learning-based weather prediction (</a:t>
-            </a:r>
-            <a:r>
-              <a:rPr lang="en-US" sz="2400" b="1">
-                <a:solidFill>
-                  <a:srgbClr val="E9EAED"/>
-                </a:solidFill>
-                <a:latin typeface="Bahnschrift SemiBold SemiConden" panose="020B0502040204020203" pitchFamily="34" charset="0"/>
-              </a:rPr>
-              <a:t>MLWP)</a:t>
+              <a:t>Hybrid-MLWP: Enhancing Numerical Weather Prediction (NWP)</a:t>
             </a:r>
             <a:endParaRPr lang="en-US" dirty="0"/>
           </a:p>
@@ -4519,7 +4508,7 @@
         </p:nvSpPr>
         <p:spPr>
           <a:xfrm>
-            <a:off x="6713622" y="662599"/>
+            <a:off x="6472993" y="662599"/>
             <a:ext cx="3746332" cy="584775"/>
           </a:xfrm>
           <a:prstGeom prst="rect">

</xml_diff>